<commit_message>
Adiciona payback do investimento e modelo de franquia
- Plano de negócios: seção 11.5 (payback ~11-16 meses no cenário-base) e
  seção 12.5 (modelo de franquia como via de expansão que não depende só
  de capital de investidor: taxa de franquia, royalty, fundo de marketing).
- Modelo financeiro: nova aba "Payback e Franquia" com EBITDA acumulado,
  payback interpolado (matriz e franqueado) e receita da franqueadora por
  unidade.
- Deck: 2 novos slides (payback e estrutura de franquia).
- Documento Word atualizado com as mesmas seções.

Co-Authored-By: Claude Sonnet 5 <noreply@anthropic.com>
</commit_message>
<xml_diff>
--- a/materiais-investidores/Deck_Investidores.pptx
+++ b/materiais-investidores/Deck_Investidores.pptx
@@ -19,9 +19,11 @@
     <p:sldId id="267" r:id="rId13"/>
     <p:sldId id="268" r:id="rId14"/>
     <p:sldId id="269" r:id="rId15"/>
+    <p:sldId id="270" r:id="rId16"/>
+    <p:sldId id="271" r:id="rId17"/>
   </p:sldIdLst>
   <p:notesMasterIdLst>
-    <p:notesMasterId r:id="rId16"/>
+    <p:notesMasterId r:id="rId18"/>
   </p:notesMasterIdLst>
   <p:sldSz cx="12192000" cy="6858000"/>
   <p:notesSz cx="6858000" cy="12192000"/>
@@ -2037,6 +2039,182 @@
             <a:fld id="{F7021451-1387-4CA6-816F-3879F97B5CBC}" type="slidenum">
               <a:rPr lang="en-US"/>
               <a:t>14</a:t>
+            </a:fld>
+            <a:endParaRPr lang="en-US"/>
+          </a:p>
+        </p:txBody>
+      </p:sp>
+    </p:spTree>
+    <p:extLst>
+      <p:ext uri="{BB962C8B-B14F-4D97-AF65-F5344CB8AC3E}">
+        <p14:creationId xmlns:p14="http://schemas.microsoft.com/office/powerpoint/2010/main" val="1024086991"/>
+      </p:ext>
+    </p:extLst>
+  </p:cSld>
+  <p:clrMapOvr>
+    <a:masterClrMapping/>
+  </p:clrMapOvr>
+</p:notes>
+</file>
+
+<file path=ppt/notesSlides/notesSlide15.xml><?xml version="1.0" encoding="utf-8"?>
+<p:notes xmlns:a="http://schemas.openxmlformats.org/drawingml/2006/main" xmlns:r="http://schemas.openxmlformats.org/officeDocument/2006/relationships" xmlns:p="http://schemas.openxmlformats.org/presentationml/2006/main">
+  <p:cSld>
+    <p:spTree>
+      <p:nvGrpSpPr>
+        <p:cNvPr id="1" name=""/>
+        <p:cNvGrpSpPr/>
+        <p:nvPr/>
+      </p:nvGrpSpPr>
+      <p:grpSpPr>
+        <a:xfrm>
+          <a:off x="0" y="0"/>
+          <a:ext cx="0" cy="0"/>
+          <a:chOff x="0" y="0"/>
+          <a:chExt cx="0" cy="0"/>
+        </a:xfrm>
+      </p:grpSpPr>
+      <p:sp>
+        <p:nvSpPr>
+          <p:cNvPr id="2" name="Slide Image Placeholder 1"/>
+          <p:cNvSpPr>
+            <a:spLocks noGrp="1" noRot="1" noChangeAspect="1"/>
+          </p:cNvSpPr>
+          <p:nvPr>
+            <p:ph type="sldImg"/>
+          </p:nvPr>
+        </p:nvSpPr>
+        <p:spPr/>
+      </p:sp>
+      <p:sp>
+        <p:nvSpPr>
+          <p:cNvPr id="3" name="Notes Placeholder 2"/>
+          <p:cNvSpPr>
+            <a:spLocks noGrp="1"/>
+          </p:cNvSpPr>
+          <p:nvPr>
+            <p:ph type="body" idx="1"/>
+          </p:nvPr>
+        </p:nvSpPr>
+        <p:spPr/>
+        <p:txBody>
+          <a:bodyPr/>
+          <a:lstStyle/>
+          <a:p>
+            <a:r>
+              <a:rPr lang="en-US" dirty="0"/>
+              <a:t/>
+            </a:r>
+            <a:endParaRPr lang="en-US" dirty="0"/>
+          </a:p>
+        </p:txBody>
+      </p:sp>
+      <p:sp>
+        <p:nvSpPr>
+          <p:cNvPr id="4" name="Slide Number Placeholder 3"/>
+          <p:cNvSpPr>
+            <a:spLocks noGrp="1"/>
+          </p:cNvSpPr>
+          <p:nvPr>
+            <p:ph type="sldNum" sz="quarter" idx="10"/>
+          </p:nvPr>
+        </p:nvSpPr>
+        <p:spPr/>
+        <p:txBody>
+          <a:bodyPr/>
+          <a:lstStyle/>
+          <a:p>
+            <a:fld id="{F7021451-1387-4CA6-816F-3879F97B5CBC}" type="slidenum">
+              <a:rPr lang="en-US"/>
+              <a:t>15</a:t>
+            </a:fld>
+            <a:endParaRPr lang="en-US"/>
+          </a:p>
+        </p:txBody>
+      </p:sp>
+    </p:spTree>
+    <p:extLst>
+      <p:ext uri="{BB962C8B-B14F-4D97-AF65-F5344CB8AC3E}">
+        <p14:creationId xmlns:p14="http://schemas.microsoft.com/office/powerpoint/2010/main" val="1024086991"/>
+      </p:ext>
+    </p:extLst>
+  </p:cSld>
+  <p:clrMapOvr>
+    <a:masterClrMapping/>
+  </p:clrMapOvr>
+</p:notes>
+</file>
+
+<file path=ppt/notesSlides/notesSlide16.xml><?xml version="1.0" encoding="utf-8"?>
+<p:notes xmlns:a="http://schemas.openxmlformats.org/drawingml/2006/main" xmlns:r="http://schemas.openxmlformats.org/officeDocument/2006/relationships" xmlns:p="http://schemas.openxmlformats.org/presentationml/2006/main">
+  <p:cSld>
+    <p:spTree>
+      <p:nvGrpSpPr>
+        <p:cNvPr id="1" name=""/>
+        <p:cNvGrpSpPr/>
+        <p:nvPr/>
+      </p:nvGrpSpPr>
+      <p:grpSpPr>
+        <a:xfrm>
+          <a:off x="0" y="0"/>
+          <a:ext cx="0" cy="0"/>
+          <a:chOff x="0" y="0"/>
+          <a:chExt cx="0" cy="0"/>
+        </a:xfrm>
+      </p:grpSpPr>
+      <p:sp>
+        <p:nvSpPr>
+          <p:cNvPr id="2" name="Slide Image Placeholder 1"/>
+          <p:cNvSpPr>
+            <a:spLocks noGrp="1" noRot="1" noChangeAspect="1"/>
+          </p:cNvSpPr>
+          <p:nvPr>
+            <p:ph type="sldImg"/>
+          </p:nvPr>
+        </p:nvSpPr>
+        <p:spPr/>
+      </p:sp>
+      <p:sp>
+        <p:nvSpPr>
+          <p:cNvPr id="3" name="Notes Placeholder 2"/>
+          <p:cNvSpPr>
+            <a:spLocks noGrp="1"/>
+          </p:cNvSpPr>
+          <p:nvPr>
+            <p:ph type="body" idx="1"/>
+          </p:nvPr>
+        </p:nvSpPr>
+        <p:spPr/>
+        <p:txBody>
+          <a:bodyPr/>
+          <a:lstStyle/>
+          <a:p>
+            <a:r>
+              <a:rPr lang="en-US" dirty="0"/>
+              <a:t/>
+            </a:r>
+            <a:endParaRPr lang="en-US" dirty="0"/>
+          </a:p>
+        </p:txBody>
+      </p:sp>
+      <p:sp>
+        <p:nvSpPr>
+          <p:cNvPr id="4" name="Slide Number Placeholder 3"/>
+          <p:cNvSpPr>
+            <a:spLocks noGrp="1"/>
+          </p:cNvSpPr>
+          <p:nvPr>
+            <p:ph type="sldNum" sz="quarter" idx="10"/>
+          </p:nvPr>
+        </p:nvSpPr>
+        <p:spPr/>
+        <p:txBody>
+          <a:bodyPr/>
+          <a:lstStyle/>
+          <a:p>
+            <a:fld id="{F7021451-1387-4CA6-816F-3879F97B5CBC}" type="slidenum">
+              <a:rPr lang="en-US"/>
+              <a:t>16</a:t>
             </a:fld>
             <a:endParaRPr lang="en-US"/>
           </a:p>
@@ -6503,6 +6681,1701 @@
       </p:grpSpPr>
       <p:sp>
         <p:nvSpPr>
+          <p:cNvPr id="2" name="Text 0"/>
+          <p:cNvSpPr/>
+          <p:nvPr/>
+        </p:nvSpPr>
+        <p:spPr>
+          <a:xfrm>
+            <a:off x="548640" y="411480"/>
+            <a:ext cx="7315200" cy="320040"/>
+          </a:xfrm>
+          <a:prstGeom prst="rect">
+            <a:avLst/>
+          </a:prstGeom>
+          <a:noFill/>
+          <a:ln/>
+        </p:spPr>
+        <p:txBody>
+          <a:bodyPr wrap="square" lIns="0" tIns="0" rIns="0" bIns="0" rtlCol="0" anchor="ctr"/>
+          <a:lstStyle/>
+          <a:p>
+            <a:pPr indent="0" marL="0">
+              <a:buNone/>
+            </a:pPr>
+            <a:r>
+              <a:rPr lang="en-US" sz="1300" b="1" spc="200" kern="0" dirty="0">
+                <a:solidFill>
+                  <a:srgbClr val="97BC62"/>
+                </a:solidFill>
+                <a:latin typeface="Calibri" pitchFamily="34" charset="0"/>
+                <a:ea typeface="Calibri" pitchFamily="34" charset="-122"/>
+                <a:cs typeface="Calibri" pitchFamily="34" charset="-120"/>
+              </a:rPr>
+              <a:t>PAYBACK DO INVESTIMENTO</a:t>
+            </a:r>
+            <a:endParaRPr lang="en-US" sz="1300" dirty="0"/>
+          </a:p>
+        </p:txBody>
+      </p:sp>
+      <p:sp>
+        <p:nvSpPr>
+          <p:cNvPr id="3" name="Text 1"/>
+          <p:cNvSpPr/>
+          <p:nvPr/>
+        </p:nvSpPr>
+        <p:spPr>
+          <a:xfrm>
+            <a:off x="548640" y="713232"/>
+            <a:ext cx="11064240" cy="822960"/>
+          </a:xfrm>
+          <a:prstGeom prst="rect">
+            <a:avLst/>
+          </a:prstGeom>
+          <a:noFill/>
+          <a:ln/>
+        </p:spPr>
+        <p:txBody>
+          <a:bodyPr wrap="square" lIns="0" tIns="0" rIns="0" bIns="0" rtlCol="0" anchor="ctr"/>
+          <a:lstStyle/>
+          <a:p>
+            <a:pPr indent="0" marL="0">
+              <a:buNone/>
+            </a:pPr>
+            <a:r>
+              <a:rPr lang="en-US" sz="3200" b="1" dirty="0">
+                <a:solidFill>
+                  <a:srgbClr val="FFFFFF"/>
+                </a:solidFill>
+                <a:latin typeface="Cambria" pitchFamily="34" charset="0"/>
+                <a:ea typeface="Cambria" pitchFamily="34" charset="-122"/>
+                <a:cs typeface="Cambria" pitchFamily="34" charset="-120"/>
+              </a:rPr>
+              <a:t>O investimento se paga em 11 a 16 meses no cenário-base</a:t>
+            </a:r>
+            <a:endParaRPr lang="en-US" sz="3200" dirty="0"/>
+          </a:p>
+        </p:txBody>
+      </p:sp>
+      <p:sp>
+        <p:nvSpPr>
+          <p:cNvPr id="4" name="Shape 2"/>
+          <p:cNvSpPr/>
+          <p:nvPr/>
+        </p:nvSpPr>
+        <p:spPr>
+          <a:xfrm>
+            <a:off x="1554480" y="2103120"/>
+            <a:ext cx="2286000" cy="2286000"/>
+          </a:xfrm>
+          <a:prstGeom prst="ellipse">
+            <a:avLst/>
+          </a:prstGeom>
+          <a:solidFill>
+            <a:srgbClr val="2C5F2D"/>
+          </a:solidFill>
+          <a:ln/>
+          <a:effectLst>
+            <a:outerShdw sx="100000" sy="100000" kx="0" ky="0" algn="bl" rotWithShape="0" blurRad="101600" dist="38100" dir="5400000">
+              <a:srgbClr val="1C2620">
+                <a:alpha val="18000"/>
+              </a:srgbClr>
+            </a:outerShdw>
+          </a:effectLst>
+        </p:spPr>
+      </p:sp>
+      <p:sp>
+        <p:nvSpPr>
+          <p:cNvPr id="5" name="Text 3"/>
+          <p:cNvSpPr/>
+          <p:nvPr/>
+        </p:nvSpPr>
+        <p:spPr>
+          <a:xfrm>
+            <a:off x="1554480" y="2606040"/>
+            <a:ext cx="2286000" cy="914400"/>
+          </a:xfrm>
+          <a:prstGeom prst="rect">
+            <a:avLst/>
+          </a:prstGeom>
+          <a:noFill/>
+          <a:ln/>
+        </p:spPr>
+        <p:txBody>
+          <a:bodyPr wrap="square" lIns="0" tIns="0" rIns="0" bIns="0" rtlCol="0" anchor="ctr"/>
+          <a:lstStyle/>
+          <a:p>
+            <a:pPr algn="ctr" indent="0" marL="0">
+              <a:buNone/>
+            </a:pPr>
+            <a:r>
+              <a:rPr lang="en-US" sz="2600" b="1" dirty="0">
+                <a:solidFill>
+                  <a:srgbClr val="FFFFFF"/>
+                </a:solidFill>
+                <a:latin typeface="Cambria" pitchFamily="34" charset="0"/>
+                <a:ea typeface="Cambria" pitchFamily="34" charset="-122"/>
+                <a:cs typeface="Cambria" pitchFamily="34" charset="-120"/>
+              </a:rPr>
+              <a:t>~11 meses</a:t>
+            </a:r>
+            <a:endParaRPr lang="en-US" sz="2600" dirty="0"/>
+          </a:p>
+        </p:txBody>
+      </p:sp>
+      <p:sp>
+        <p:nvSpPr>
+          <p:cNvPr id="6" name="Text 4"/>
+          <p:cNvSpPr/>
+          <p:nvPr/>
+        </p:nvSpPr>
+        <p:spPr>
+          <a:xfrm>
+            <a:off x="1737360" y="3429000"/>
+            <a:ext cx="1920240" cy="800100"/>
+          </a:xfrm>
+          <a:prstGeom prst="rect">
+            <a:avLst/>
+          </a:prstGeom>
+          <a:noFill/>
+          <a:ln/>
+        </p:spPr>
+        <p:txBody>
+          <a:bodyPr wrap="square" lIns="0" tIns="0" rIns="0" bIns="0" rtlCol="0" anchor="ctr"/>
+          <a:lstStyle/>
+          <a:p>
+            <a:pPr algn="ctr" indent="0" marL="0">
+              <a:buNone/>
+            </a:pPr>
+            <a:r>
+              <a:rPr lang="en-US" sz="950" dirty="0">
+                <a:solidFill>
+                  <a:srgbClr val="FFFFFF"/>
+                </a:solidFill>
+                <a:latin typeface="Calibri" pitchFamily="34" charset="0"/>
+                <a:ea typeface="Calibri" pitchFamily="34" charset="-122"/>
+                <a:cs typeface="Calibri" pitchFamily="34" charset="-120"/>
+              </a:rPr>
+              <a:t>payback sobre</a:t>
+            </a:r>
+            <a:endParaRPr lang="en-US" sz="950" dirty="0"/>
+          </a:p>
+          <a:p>
+            <a:pPr algn="ctr" indent="0" marL="0">
+              <a:buNone/>
+            </a:pPr>
+            <a:r>
+              <a:rPr lang="en-US" sz="950" dirty="0">
+                <a:solidFill>
+                  <a:srgbClr val="FFFFFF"/>
+                </a:solidFill>
+                <a:latin typeface="Calibri" pitchFamily="34" charset="0"/>
+                <a:ea typeface="Calibri" pitchFamily="34" charset="-122"/>
+                <a:cs typeface="Calibri" pitchFamily="34" charset="-120"/>
+              </a:rPr>
+              <a:t>R$ 275k (piso)</a:t>
+            </a:r>
+            <a:endParaRPr lang="en-US" sz="950" dirty="0"/>
+          </a:p>
+        </p:txBody>
+      </p:sp>
+      <p:sp>
+        <p:nvSpPr>
+          <p:cNvPr id="7" name="Shape 5"/>
+          <p:cNvSpPr/>
+          <p:nvPr/>
+        </p:nvSpPr>
+        <p:spPr>
+          <a:xfrm>
+            <a:off x="4572000" y="2103120"/>
+            <a:ext cx="2286000" cy="2286000"/>
+          </a:xfrm>
+          <a:prstGeom prst="ellipse">
+            <a:avLst/>
+          </a:prstGeom>
+          <a:solidFill>
+            <a:srgbClr val="8A5A22"/>
+          </a:solidFill>
+          <a:ln/>
+          <a:effectLst>
+            <a:outerShdw sx="100000" sy="100000" kx="0" ky="0" algn="bl" rotWithShape="0" blurRad="101600" dist="38100" dir="5400000">
+              <a:srgbClr val="1C2620">
+                <a:alpha val="18000"/>
+              </a:srgbClr>
+            </a:outerShdw>
+          </a:effectLst>
+        </p:spPr>
+      </p:sp>
+      <p:sp>
+        <p:nvSpPr>
+          <p:cNvPr id="8" name="Text 6"/>
+          <p:cNvSpPr/>
+          <p:nvPr/>
+        </p:nvSpPr>
+        <p:spPr>
+          <a:xfrm>
+            <a:off x="4572000" y="2606040"/>
+            <a:ext cx="2286000" cy="914400"/>
+          </a:xfrm>
+          <a:prstGeom prst="rect">
+            <a:avLst/>
+          </a:prstGeom>
+          <a:noFill/>
+          <a:ln/>
+        </p:spPr>
+        <p:txBody>
+          <a:bodyPr wrap="square" lIns="0" tIns="0" rIns="0" bIns="0" rtlCol="0" anchor="ctr"/>
+          <a:lstStyle/>
+          <a:p>
+            <a:pPr algn="ctr" indent="0" marL="0">
+              <a:buNone/>
+            </a:pPr>
+            <a:r>
+              <a:rPr lang="en-US" sz="2600" b="1" dirty="0">
+                <a:solidFill>
+                  <a:srgbClr val="FFFFFF"/>
+                </a:solidFill>
+                <a:latin typeface="Cambria" pitchFamily="34" charset="0"/>
+                <a:ea typeface="Cambria" pitchFamily="34" charset="-122"/>
+                <a:cs typeface="Cambria" pitchFamily="34" charset="-120"/>
+              </a:rPr>
+              <a:t>~16 meses</a:t>
+            </a:r>
+            <a:endParaRPr lang="en-US" sz="2600" dirty="0"/>
+          </a:p>
+        </p:txBody>
+      </p:sp>
+      <p:sp>
+        <p:nvSpPr>
+          <p:cNvPr id="9" name="Text 7"/>
+          <p:cNvSpPr/>
+          <p:nvPr/>
+        </p:nvSpPr>
+        <p:spPr>
+          <a:xfrm>
+            <a:off x="4754880" y="3429000"/>
+            <a:ext cx="1920240" cy="800100"/>
+          </a:xfrm>
+          <a:prstGeom prst="rect">
+            <a:avLst/>
+          </a:prstGeom>
+          <a:noFill/>
+          <a:ln/>
+        </p:spPr>
+        <p:txBody>
+          <a:bodyPr wrap="square" lIns="0" tIns="0" rIns="0" bIns="0" rtlCol="0" anchor="ctr"/>
+          <a:lstStyle/>
+          <a:p>
+            <a:pPr algn="ctr" indent="0" marL="0">
+              <a:buNone/>
+            </a:pPr>
+            <a:r>
+              <a:rPr lang="en-US" sz="950" dirty="0">
+                <a:solidFill>
+                  <a:srgbClr val="FFFFFF"/>
+                </a:solidFill>
+                <a:latin typeface="Calibri" pitchFamily="34" charset="0"/>
+                <a:ea typeface="Calibri" pitchFamily="34" charset="-122"/>
+                <a:cs typeface="Calibri" pitchFamily="34" charset="-120"/>
+              </a:rPr>
+              <a:t>payback sobre</a:t>
+            </a:r>
+            <a:endParaRPr lang="en-US" sz="950" dirty="0"/>
+          </a:p>
+          <a:p>
+            <a:pPr algn="ctr" indent="0" marL="0">
+              <a:buNone/>
+            </a:pPr>
+            <a:r>
+              <a:rPr lang="en-US" sz="950" dirty="0">
+                <a:solidFill>
+                  <a:srgbClr val="FFFFFF"/>
+                </a:solidFill>
+                <a:latin typeface="Calibri" pitchFamily="34" charset="0"/>
+                <a:ea typeface="Calibri" pitchFamily="34" charset="-122"/>
+                <a:cs typeface="Calibri" pitchFamily="34" charset="-120"/>
+              </a:rPr>
+              <a:t>R$ 580k (teto)</a:t>
+            </a:r>
+            <a:endParaRPr lang="en-US" sz="950" dirty="0"/>
+          </a:p>
+        </p:txBody>
+      </p:sp>
+      <p:sp>
+        <p:nvSpPr>
+          <p:cNvPr id="10" name="Text 8"/>
+          <p:cNvSpPr/>
+          <p:nvPr/>
+        </p:nvSpPr>
+        <p:spPr>
+          <a:xfrm>
+            <a:off x="822960" y="4617720"/>
+            <a:ext cx="10332720" cy="320040"/>
+          </a:xfrm>
+          <a:prstGeom prst="rect">
+            <a:avLst/>
+          </a:prstGeom>
+          <a:noFill/>
+          <a:ln/>
+        </p:spPr>
+        <p:txBody>
+          <a:bodyPr wrap="square" lIns="0" tIns="0" rIns="0" bIns="0" rtlCol="0" anchor="ctr"/>
+          <a:lstStyle/>
+          <a:p>
+            <a:pPr indent="0" marL="0">
+              <a:buNone/>
+            </a:pPr>
+            <a:r>
+              <a:rPr lang="en-US" sz="1100" i="1" dirty="0">
+                <a:solidFill>
+                  <a:srgbClr val="9CB79F"/>
+                </a:solidFill>
+                <a:latin typeface="Calibri" pitchFamily="34" charset="0"/>
+                <a:ea typeface="Calibri" pitchFamily="34" charset="-122"/>
+                <a:cs typeface="Calibri" pitchFamily="34" charset="-120"/>
+              </a:rPr>
+              <a:t>Cálculo: EBITDA mensal acumulado (cenário-base do modelo financeiro) cruzando o investimento inicial total.</a:t>
+            </a:r>
+            <a:endParaRPr lang="en-US" sz="1100" dirty="0"/>
+          </a:p>
+        </p:txBody>
+      </p:sp>
+      <p:sp>
+        <p:nvSpPr>
+          <p:cNvPr id="11" name="Text 9"/>
+          <p:cNvSpPr/>
+          <p:nvPr/>
+        </p:nvSpPr>
+        <p:spPr>
+          <a:xfrm>
+            <a:off x="822960" y="5257800"/>
+            <a:ext cx="10332720" cy="320040"/>
+          </a:xfrm>
+          <a:prstGeom prst="rect">
+            <a:avLst/>
+          </a:prstGeom>
+          <a:noFill/>
+          <a:ln/>
+        </p:spPr>
+        <p:txBody>
+          <a:bodyPr wrap="square" lIns="0" tIns="0" rIns="0" bIns="0" rtlCol="0" anchor="ctr"/>
+          <a:lstStyle/>
+          <a:p>
+            <a:pPr indent="0" marL="0">
+              <a:buNone/>
+            </a:pPr>
+            <a:r>
+              <a:rPr lang="en-US" sz="1500" b="1" dirty="0">
+                <a:solidFill>
+                  <a:srgbClr val="C97A2B"/>
+                </a:solidFill>
+                <a:latin typeface="Cambria" pitchFamily="34" charset="0"/>
+                <a:ea typeface="Cambria" pitchFamily="34" charset="-122"/>
+                <a:cs typeface="Cambria" pitchFamily="34" charset="-120"/>
+              </a:rPr>
+              <a:t>Ressalva importante</a:t>
+            </a:r>
+            <a:endParaRPr lang="en-US" sz="1500" dirty="0"/>
+          </a:p>
+        </p:txBody>
+      </p:sp>
+      <p:sp>
+        <p:nvSpPr>
+          <p:cNvPr id="12" name="Text 10"/>
+          <p:cNvSpPr/>
+          <p:nvPr/>
+        </p:nvSpPr>
+        <p:spPr>
+          <a:xfrm>
+            <a:off x="822960" y="5623560"/>
+            <a:ext cx="10332720" cy="640080"/>
+          </a:xfrm>
+          <a:prstGeom prst="rect">
+            <a:avLst/>
+          </a:prstGeom>
+          <a:noFill/>
+          <a:ln/>
+        </p:spPr>
+        <p:txBody>
+          <a:bodyPr wrap="square" lIns="0" tIns="0" rIns="0" bIns="0" rtlCol="0" anchor="ctr"/>
+          <a:lstStyle/>
+          <a:p>
+            <a:pPr indent="0" marL="0">
+              <a:buNone/>
+            </a:pPr>
+            <a:r>
+              <a:rPr lang="en-US" sz="1300" dirty="0">
+                <a:solidFill>
+                  <a:srgbClr val="D8E6D9"/>
+                </a:solidFill>
+                <a:latin typeface="Calibri" pitchFamily="34" charset="0"/>
+                <a:ea typeface="Calibri" pitchFamily="34" charset="-122"/>
+                <a:cs typeface="Calibri" pitchFamily="34" charset="-120"/>
+              </a:rPr>
+              <a:t>Este payback vem das premissas de modelo (churn 9%, CAC R$140, margem de contribuição ~30%) — ainda não validadas com dados reais. Deve ser apresentado com essa ressalva, e recalculado com os números do piloto (Fase 0).</a:t>
+            </a:r>
+            <a:endParaRPr lang="en-US" sz="1300" dirty="0"/>
+          </a:p>
+        </p:txBody>
+      </p:sp>
+      <p:sp>
+        <p:nvSpPr>
+          <p:cNvPr id="13" name="Text 11"/>
+          <p:cNvSpPr/>
+          <p:nvPr/>
+        </p:nvSpPr>
+        <p:spPr>
+          <a:xfrm>
+            <a:off x="457200" y="6510528"/>
+            <a:ext cx="7315200" cy="274320"/>
+          </a:xfrm>
+          <a:prstGeom prst="rect">
+            <a:avLst/>
+          </a:prstGeom>
+          <a:noFill/>
+          <a:ln/>
+        </p:spPr>
+        <p:txBody>
+          <a:bodyPr wrap="square" lIns="0" tIns="0" rIns="0" bIns="0" rtlCol="0" anchor="ctr"/>
+          <a:lstStyle/>
+          <a:p>
+            <a:pPr indent="0" marL="0">
+              <a:buNone/>
+            </a:pPr>
+            <a:r>
+              <a:rPr lang="en-US" sz="900" dirty="0">
+                <a:solidFill>
+                  <a:srgbClr val="9CB79F"/>
+                </a:solidFill>
+                <a:latin typeface="Calibri" pitchFamily="34" charset="0"/>
+                <a:ea typeface="Calibri" pitchFamily="34" charset="-122"/>
+                <a:cs typeface="Calibri" pitchFamily="34" charset="-120"/>
+              </a:rPr>
+              <a:t>Clube.org — Plano de Negócios &amp; Investimento</a:t>
+            </a:r>
+            <a:endParaRPr lang="en-US" sz="900" dirty="0"/>
+          </a:p>
+        </p:txBody>
+      </p:sp>
+      <p:sp>
+        <p:nvSpPr>
+          <p:cNvPr id="14" name="Text 12"/>
+          <p:cNvSpPr/>
+          <p:nvPr/>
+        </p:nvSpPr>
+        <p:spPr>
+          <a:xfrm>
+            <a:off x="11430000" y="6510528"/>
+            <a:ext cx="365760" cy="274320"/>
+          </a:xfrm>
+          <a:prstGeom prst="rect">
+            <a:avLst/>
+          </a:prstGeom>
+          <a:noFill/>
+          <a:ln/>
+        </p:spPr>
+        <p:txBody>
+          <a:bodyPr wrap="square" lIns="0" tIns="0" rIns="0" bIns="0" rtlCol="0" anchor="ctr"/>
+          <a:lstStyle/>
+          <a:p>
+            <a:pPr algn="r" indent="0" marL="0">
+              <a:buNone/>
+            </a:pPr>
+            <a:r>
+              <a:rPr lang="en-US" sz="900" dirty="0">
+                <a:solidFill>
+                  <a:srgbClr val="9CB79F"/>
+                </a:solidFill>
+                <a:latin typeface="Calibri" pitchFamily="34" charset="0"/>
+                <a:ea typeface="Calibri" pitchFamily="34" charset="-122"/>
+                <a:cs typeface="Calibri" pitchFamily="34" charset="-120"/>
+              </a:rPr>
+              <a:t>14</a:t>
+            </a:r>
+            <a:endParaRPr lang="en-US" sz="900" dirty="0"/>
+          </a:p>
+        </p:txBody>
+      </p:sp>
+    </p:spTree>
+  </p:cSld>
+  <p:clrMapOvr>
+    <a:masterClrMapping/>
+  </p:clrMapOvr>
+</p:sld>
+</file>
+
+<file path=ppt/slides/slide15.xml><?xml version="1.0" encoding="utf-8"?>
+<p:sld xmlns:a="http://schemas.openxmlformats.org/drawingml/2006/main" xmlns:r="http://schemas.openxmlformats.org/officeDocument/2006/relationships" xmlns:p="http://schemas.openxmlformats.org/presentationml/2006/main">
+  <p:cSld name="Slide 15">
+    <p:bg>
+      <p:bgPr>
+        <a:solidFill>
+          <a:srgbClr val="FFFFFF"/>
+        </a:solidFill>
+      </p:bgPr>
+    </p:bg>
+    <p:spTree>
+      <p:nvGrpSpPr>
+        <p:cNvPr id="1" name=""/>
+        <p:cNvGrpSpPr/>
+        <p:nvPr/>
+      </p:nvGrpSpPr>
+      <p:grpSpPr>
+        <a:xfrm>
+          <a:off x="0" y="0"/>
+          <a:ext cx="0" cy="0"/>
+          <a:chOff x="0" y="0"/>
+          <a:chExt cx="0" cy="0"/>
+        </a:xfrm>
+      </p:grpSpPr>
+      <p:sp>
+        <p:nvSpPr>
+          <p:cNvPr id="2" name="Text 0"/>
+          <p:cNvSpPr/>
+          <p:nvPr/>
+        </p:nvSpPr>
+        <p:spPr>
+          <a:xfrm>
+            <a:off x="548640" y="411480"/>
+            <a:ext cx="7315200" cy="320040"/>
+          </a:xfrm>
+          <a:prstGeom prst="rect">
+            <a:avLst/>
+          </a:prstGeom>
+          <a:noFill/>
+          <a:ln/>
+        </p:spPr>
+        <p:txBody>
+          <a:bodyPr wrap="square" lIns="0" tIns="0" rIns="0" bIns="0" rtlCol="0" anchor="ctr"/>
+          <a:lstStyle/>
+          <a:p>
+            <a:pPr indent="0" marL="0">
+              <a:buNone/>
+            </a:pPr>
+            <a:r>
+              <a:rPr lang="en-US" sz="1300" b="1" spc="200" kern="0" dirty="0">
+                <a:solidFill>
+                  <a:srgbClr val="C97A2B"/>
+                </a:solidFill>
+                <a:latin typeface="Calibri" pitchFamily="34" charset="0"/>
+                <a:ea typeface="Calibri" pitchFamily="34" charset="-122"/>
+                <a:cs typeface="Calibri" pitchFamily="34" charset="-120"/>
+              </a:rPr>
+              <a:t>EXPANSÃO SEM DEPENDER SÓ DE INVESTIDOR</a:t>
+            </a:r>
+            <a:endParaRPr lang="en-US" sz="1300" dirty="0"/>
+          </a:p>
+        </p:txBody>
+      </p:sp>
+      <p:sp>
+        <p:nvSpPr>
+          <p:cNvPr id="3" name="Text 1"/>
+          <p:cNvSpPr/>
+          <p:nvPr/>
+        </p:nvSpPr>
+        <p:spPr>
+          <a:xfrm>
+            <a:off x="548640" y="713232"/>
+            <a:ext cx="11064240" cy="822960"/>
+          </a:xfrm>
+          <a:prstGeom prst="rect">
+            <a:avLst/>
+          </a:prstGeom>
+          <a:noFill/>
+          <a:ln/>
+        </p:spPr>
+        <p:txBody>
+          <a:bodyPr wrap="square" lIns="0" tIns="0" rIns="0" bIns="0" rtlCol="0" anchor="ctr"/>
+          <a:lstStyle/>
+          <a:p>
+            <a:pPr indent="0" marL="0">
+              <a:buNone/>
+            </a:pPr>
+            <a:r>
+              <a:rPr lang="en-US" sz="3200" b="1" dirty="0">
+                <a:solidFill>
+                  <a:srgbClr val="1F3D24"/>
+                </a:solidFill>
+                <a:latin typeface="Cambria" pitchFamily="34" charset="0"/>
+                <a:ea typeface="Cambria" pitchFamily="34" charset="-122"/>
+                <a:cs typeface="Cambria" pitchFamily="34" charset="-120"/>
+              </a:rPr>
+              <a:t>Modelo de franquia: o operador local capitaliza o CD</a:t>
+            </a:r>
+            <a:endParaRPr lang="en-US" sz="3200" dirty="0"/>
+          </a:p>
+        </p:txBody>
+      </p:sp>
+      <p:sp>
+        <p:nvSpPr>
+          <p:cNvPr id="4" name="Shape 2"/>
+          <p:cNvSpPr/>
+          <p:nvPr/>
+        </p:nvSpPr>
+        <p:spPr>
+          <a:xfrm>
+            <a:off x="548640" y="1783080"/>
+            <a:ext cx="5349240" cy="2651760"/>
+          </a:xfrm>
+          <a:prstGeom prst="roundRect">
+            <a:avLst>
+              <a:gd name="adj" fmla="val 2759"/>
+            </a:avLst>
+          </a:prstGeom>
+          <a:solidFill>
+            <a:srgbClr val="1F3D24"/>
+          </a:solidFill>
+          <a:ln/>
+          <a:effectLst>
+            <a:outerShdw sx="100000" sy="100000" kx="0" ky="0" algn="bl" rotWithShape="0" blurRad="101600" dist="38100" dir="5400000">
+              <a:srgbClr val="1C2620">
+                <a:alpha val="18000"/>
+              </a:srgbClr>
+            </a:outerShdw>
+          </a:effectLst>
+        </p:spPr>
+      </p:sp>
+      <p:sp>
+        <p:nvSpPr>
+          <p:cNvPr id="5" name="Text 3"/>
+          <p:cNvSpPr/>
+          <p:nvPr/>
+        </p:nvSpPr>
+        <p:spPr>
+          <a:xfrm>
+            <a:off x="822960" y="2011680"/>
+            <a:ext cx="4800600" cy="411480"/>
+          </a:xfrm>
+          <a:prstGeom prst="rect">
+            <a:avLst/>
+          </a:prstGeom>
+          <a:noFill/>
+          <a:ln/>
+        </p:spPr>
+        <p:txBody>
+          <a:bodyPr wrap="square" lIns="0" tIns="0" rIns="0" bIns="0" rtlCol="0" anchor="ctr"/>
+          <a:lstStyle/>
+          <a:p>
+            <a:pPr indent="0" marL="0">
+              <a:buNone/>
+            </a:pPr>
+            <a:r>
+              <a:rPr lang="en-US" sz="1500" b="1" dirty="0">
+                <a:solidFill>
+                  <a:srgbClr val="FFFFFF"/>
+                </a:solidFill>
+                <a:latin typeface="Cambria" pitchFamily="34" charset="0"/>
+                <a:ea typeface="Cambria" pitchFamily="34" charset="-122"/>
+                <a:cs typeface="Cambria" pitchFamily="34" charset="-120"/>
+              </a:rPr>
+              <a:t>Franqueadora (matriz)</a:t>
+            </a:r>
+            <a:endParaRPr lang="en-US" sz="1500" dirty="0"/>
+          </a:p>
+        </p:txBody>
+      </p:sp>
+      <p:sp>
+        <p:nvSpPr>
+          <p:cNvPr id="6" name="Shape 4"/>
+          <p:cNvSpPr/>
+          <p:nvPr/>
+        </p:nvSpPr>
+        <p:spPr>
+          <a:xfrm>
+            <a:off x="822960" y="2606040"/>
+            <a:ext cx="109728" cy="109728"/>
+          </a:xfrm>
+          <a:prstGeom prst="ellipse">
+            <a:avLst/>
+          </a:prstGeom>
+          <a:solidFill>
+            <a:srgbClr val="FFFFFF"/>
+          </a:solidFill>
+          <a:ln/>
+        </p:spPr>
+      </p:sp>
+      <p:sp>
+        <p:nvSpPr>
+          <p:cNvPr id="7" name="Text 5"/>
+          <p:cNvSpPr/>
+          <p:nvPr/>
+        </p:nvSpPr>
+        <p:spPr>
+          <a:xfrm>
+            <a:off x="1051560" y="2450592"/>
+            <a:ext cx="4572000" cy="457200"/>
+          </a:xfrm>
+          <a:prstGeom prst="rect">
+            <a:avLst/>
+          </a:prstGeom>
+          <a:noFill/>
+          <a:ln/>
+        </p:spPr>
+        <p:txBody>
+          <a:bodyPr wrap="square" lIns="0" tIns="0" rIns="0" bIns="0" rtlCol="0" anchor="ctr"/>
+          <a:lstStyle/>
+          <a:p>
+            <a:pPr indent="0" marL="0">
+              <a:buNone/>
+            </a:pPr>
+            <a:r>
+              <a:rPr lang="en-US" sz="1150" dirty="0">
+                <a:solidFill>
+                  <a:srgbClr val="F0F0F0"/>
+                </a:solidFill>
+                <a:latin typeface="Calibri" pitchFamily="34" charset="0"/>
+                <a:ea typeface="Calibri" pitchFamily="34" charset="-122"/>
+                <a:cs typeface="Calibri" pitchFamily="34" charset="-120"/>
+              </a:rPr>
+              <a:t>Marca e apps (cliente + fornecedor)</a:t>
+            </a:r>
+            <a:endParaRPr lang="en-US" sz="1150" dirty="0"/>
+          </a:p>
+        </p:txBody>
+      </p:sp>
+      <p:sp>
+        <p:nvSpPr>
+          <p:cNvPr id="8" name="Shape 6"/>
+          <p:cNvSpPr/>
+          <p:nvPr/>
+        </p:nvSpPr>
+        <p:spPr>
+          <a:xfrm>
+            <a:off x="822960" y="3172968"/>
+            <a:ext cx="109728" cy="109728"/>
+          </a:xfrm>
+          <a:prstGeom prst="ellipse">
+            <a:avLst/>
+          </a:prstGeom>
+          <a:solidFill>
+            <a:srgbClr val="FFFFFF"/>
+          </a:solidFill>
+          <a:ln/>
+        </p:spPr>
+      </p:sp>
+      <p:sp>
+        <p:nvSpPr>
+          <p:cNvPr id="9" name="Text 7"/>
+          <p:cNvSpPr/>
+          <p:nvPr/>
+        </p:nvSpPr>
+        <p:spPr>
+          <a:xfrm>
+            <a:off x="1051560" y="3017520"/>
+            <a:ext cx="4572000" cy="457200"/>
+          </a:xfrm>
+          <a:prstGeom prst="rect">
+            <a:avLst/>
+          </a:prstGeom>
+          <a:noFill/>
+          <a:ln/>
+        </p:spPr>
+        <p:txBody>
+          <a:bodyPr wrap="square" lIns="0" tIns="0" rIns="0" bIns="0" rtlCol="0" anchor="ctr"/>
+          <a:lstStyle/>
+          <a:p>
+            <a:pPr indent="0" marL="0">
+              <a:buNone/>
+            </a:pPr>
+            <a:r>
+              <a:rPr lang="en-US" sz="1150" dirty="0">
+                <a:solidFill>
+                  <a:srgbClr val="F0F0F0"/>
+                </a:solidFill>
+                <a:latin typeface="Calibri" pitchFamily="34" charset="0"/>
+                <a:ea typeface="Calibri" pitchFamily="34" charset="-122"/>
+                <a:cs typeface="Calibri" pitchFamily="34" charset="-120"/>
+              </a:rPr>
+              <a:t>Playbook operacional e treinamento</a:t>
+            </a:r>
+            <a:endParaRPr lang="en-US" sz="1150" dirty="0"/>
+          </a:p>
+        </p:txBody>
+      </p:sp>
+      <p:sp>
+        <p:nvSpPr>
+          <p:cNvPr id="10" name="Shape 8"/>
+          <p:cNvSpPr/>
+          <p:nvPr/>
+        </p:nvSpPr>
+        <p:spPr>
+          <a:xfrm>
+            <a:off x="822960" y="3739896"/>
+            <a:ext cx="109728" cy="109728"/>
+          </a:xfrm>
+          <a:prstGeom prst="ellipse">
+            <a:avLst/>
+          </a:prstGeom>
+          <a:solidFill>
+            <a:srgbClr val="FFFFFF"/>
+          </a:solidFill>
+          <a:ln/>
+        </p:spPr>
+      </p:sp>
+      <p:sp>
+        <p:nvSpPr>
+          <p:cNvPr id="11" name="Text 9"/>
+          <p:cNvSpPr/>
+          <p:nvPr/>
+        </p:nvSpPr>
+        <p:spPr>
+          <a:xfrm>
+            <a:off x="1051560" y="3584448"/>
+            <a:ext cx="4572000" cy="457200"/>
+          </a:xfrm>
+          <a:prstGeom prst="rect">
+            <a:avLst/>
+          </a:prstGeom>
+          <a:noFill/>
+          <a:ln/>
+        </p:spPr>
+        <p:txBody>
+          <a:bodyPr wrap="square" lIns="0" tIns="0" rIns="0" bIns="0" rtlCol="0" anchor="ctr"/>
+          <a:lstStyle/>
+          <a:p>
+            <a:pPr indent="0" marL="0">
+              <a:buNone/>
+            </a:pPr>
+            <a:r>
+              <a:rPr lang="en-US" sz="1150" dirty="0">
+                <a:solidFill>
+                  <a:srgbClr val="F0F0F0"/>
+                </a:solidFill>
+                <a:latin typeface="Calibri" pitchFamily="34" charset="0"/>
+                <a:ea typeface="Calibri" pitchFamily="34" charset="-122"/>
+                <a:cs typeface="Calibri" pitchFamily="34" charset="-120"/>
+              </a:rPr>
+              <a:t>Curva de aprendizado do piloto</a:t>
+            </a:r>
+            <a:endParaRPr lang="en-US" sz="1150" dirty="0"/>
+          </a:p>
+        </p:txBody>
+      </p:sp>
+      <p:sp>
+        <p:nvSpPr>
+          <p:cNvPr id="12" name="Shape 10"/>
+          <p:cNvSpPr/>
+          <p:nvPr/>
+        </p:nvSpPr>
+        <p:spPr>
+          <a:xfrm>
+            <a:off x="6263640" y="1783080"/>
+            <a:ext cx="5349240" cy="2651760"/>
+          </a:xfrm>
+          <a:prstGeom prst="roundRect">
+            <a:avLst>
+              <a:gd name="adj" fmla="val 2759"/>
+            </a:avLst>
+          </a:prstGeom>
+          <a:solidFill>
+            <a:srgbClr val="97BC62"/>
+          </a:solidFill>
+          <a:ln/>
+          <a:effectLst>
+            <a:outerShdw sx="100000" sy="100000" kx="0" ky="0" algn="bl" rotWithShape="0" blurRad="101600" dist="38100" dir="5400000">
+              <a:srgbClr val="1C2620">
+                <a:alpha val="18000"/>
+              </a:srgbClr>
+            </a:outerShdw>
+          </a:effectLst>
+        </p:spPr>
+      </p:sp>
+      <p:sp>
+        <p:nvSpPr>
+          <p:cNvPr id="13" name="Text 11"/>
+          <p:cNvSpPr/>
+          <p:nvPr/>
+        </p:nvSpPr>
+        <p:spPr>
+          <a:xfrm>
+            <a:off x="6537960" y="2011680"/>
+            <a:ext cx="4800600" cy="411480"/>
+          </a:xfrm>
+          <a:prstGeom prst="rect">
+            <a:avLst/>
+          </a:prstGeom>
+          <a:noFill/>
+          <a:ln/>
+        </p:spPr>
+        <p:txBody>
+          <a:bodyPr wrap="square" lIns="0" tIns="0" rIns="0" bIns="0" rtlCol="0" anchor="ctr"/>
+          <a:lstStyle/>
+          <a:p>
+            <a:pPr indent="0" marL="0">
+              <a:buNone/>
+            </a:pPr>
+            <a:r>
+              <a:rPr lang="en-US" sz="1500" b="1" dirty="0">
+                <a:solidFill>
+                  <a:srgbClr val="FFFFFF"/>
+                </a:solidFill>
+                <a:latin typeface="Cambria" pitchFamily="34" charset="0"/>
+                <a:ea typeface="Cambria" pitchFamily="34" charset="-122"/>
+                <a:cs typeface="Cambria" pitchFamily="34" charset="-120"/>
+              </a:rPr>
+              <a:t>Franqueado (operador local)</a:t>
+            </a:r>
+            <a:endParaRPr lang="en-US" sz="1500" dirty="0"/>
+          </a:p>
+        </p:txBody>
+      </p:sp>
+      <p:sp>
+        <p:nvSpPr>
+          <p:cNvPr id="14" name="Shape 12"/>
+          <p:cNvSpPr/>
+          <p:nvPr/>
+        </p:nvSpPr>
+        <p:spPr>
+          <a:xfrm>
+            <a:off x="6537960" y="2606040"/>
+            <a:ext cx="109728" cy="109728"/>
+          </a:xfrm>
+          <a:prstGeom prst="ellipse">
+            <a:avLst/>
+          </a:prstGeom>
+          <a:solidFill>
+            <a:srgbClr val="FFFFFF"/>
+          </a:solidFill>
+          <a:ln/>
+        </p:spPr>
+      </p:sp>
+      <p:sp>
+        <p:nvSpPr>
+          <p:cNvPr id="15" name="Text 13"/>
+          <p:cNvSpPr/>
+          <p:nvPr/>
+        </p:nvSpPr>
+        <p:spPr>
+          <a:xfrm>
+            <a:off x="6766560" y="2450592"/>
+            <a:ext cx="4572000" cy="457200"/>
+          </a:xfrm>
+          <a:prstGeom prst="rect">
+            <a:avLst/>
+          </a:prstGeom>
+          <a:noFill/>
+          <a:ln/>
+        </p:spPr>
+        <p:txBody>
+          <a:bodyPr wrap="square" lIns="0" tIns="0" rIns="0" bIns="0" rtlCol="0" anchor="ctr"/>
+          <a:lstStyle/>
+          <a:p>
+            <a:pPr indent="0" marL="0">
+              <a:buNone/>
+            </a:pPr>
+            <a:r>
+              <a:rPr lang="en-US" sz="1150" dirty="0">
+                <a:solidFill>
+                  <a:srgbClr val="F0F0F0"/>
+                </a:solidFill>
+                <a:latin typeface="Calibri" pitchFamily="34" charset="0"/>
+                <a:ea typeface="Calibri" pitchFamily="34" charset="-122"/>
+                <a:cs typeface="Calibri" pitchFamily="34" charset="-120"/>
+              </a:rPr>
+              <a:t>Capital do CD local (R$ 275k–580k)</a:t>
+            </a:r>
+            <a:endParaRPr lang="en-US" sz="1150" dirty="0"/>
+          </a:p>
+        </p:txBody>
+      </p:sp>
+      <p:sp>
+        <p:nvSpPr>
+          <p:cNvPr id="16" name="Shape 14"/>
+          <p:cNvSpPr/>
+          <p:nvPr/>
+        </p:nvSpPr>
+        <p:spPr>
+          <a:xfrm>
+            <a:off x="6537960" y="3172968"/>
+            <a:ext cx="109728" cy="109728"/>
+          </a:xfrm>
+          <a:prstGeom prst="ellipse">
+            <a:avLst/>
+          </a:prstGeom>
+          <a:solidFill>
+            <a:srgbClr val="FFFFFF"/>
+          </a:solidFill>
+          <a:ln/>
+        </p:spPr>
+      </p:sp>
+      <p:sp>
+        <p:nvSpPr>
+          <p:cNvPr id="17" name="Text 15"/>
+          <p:cNvSpPr/>
+          <p:nvPr/>
+        </p:nvSpPr>
+        <p:spPr>
+          <a:xfrm>
+            <a:off x="6766560" y="3017520"/>
+            <a:ext cx="4572000" cy="457200"/>
+          </a:xfrm>
+          <a:prstGeom prst="rect">
+            <a:avLst/>
+          </a:prstGeom>
+          <a:noFill/>
+          <a:ln/>
+        </p:spPr>
+        <p:txBody>
+          <a:bodyPr wrap="square" lIns="0" tIns="0" rIns="0" bIns="0" rtlCol="0" anchor="ctr"/>
+          <a:lstStyle/>
+          <a:p>
+            <a:pPr indent="0" marL="0">
+              <a:buNone/>
+            </a:pPr>
+            <a:r>
+              <a:rPr lang="en-US" sz="1150" dirty="0">
+                <a:solidFill>
+                  <a:srgbClr val="F0F0F0"/>
+                </a:solidFill>
+                <a:latin typeface="Calibri" pitchFamily="34" charset="0"/>
+                <a:ea typeface="Calibri" pitchFamily="34" charset="-122"/>
+                <a:cs typeface="Calibri" pitchFamily="34" charset="-120"/>
+              </a:rPr>
+              <a:t>Frota e capital de giro</a:t>
+            </a:r>
+            <a:endParaRPr lang="en-US" sz="1150" dirty="0"/>
+          </a:p>
+        </p:txBody>
+      </p:sp>
+      <p:sp>
+        <p:nvSpPr>
+          <p:cNvPr id="18" name="Shape 16"/>
+          <p:cNvSpPr/>
+          <p:nvPr/>
+        </p:nvSpPr>
+        <p:spPr>
+          <a:xfrm>
+            <a:off x="6537960" y="3739896"/>
+            <a:ext cx="109728" cy="109728"/>
+          </a:xfrm>
+          <a:prstGeom prst="ellipse">
+            <a:avLst/>
+          </a:prstGeom>
+          <a:solidFill>
+            <a:srgbClr val="FFFFFF"/>
+          </a:solidFill>
+          <a:ln/>
+        </p:spPr>
+      </p:sp>
+      <p:sp>
+        <p:nvSpPr>
+          <p:cNvPr id="19" name="Text 17"/>
+          <p:cNvSpPr/>
+          <p:nvPr/>
+        </p:nvSpPr>
+        <p:spPr>
+          <a:xfrm>
+            <a:off x="6766560" y="3584448"/>
+            <a:ext cx="4572000" cy="457200"/>
+          </a:xfrm>
+          <a:prstGeom prst="rect">
+            <a:avLst/>
+          </a:prstGeom>
+          <a:noFill/>
+          <a:ln/>
+        </p:spPr>
+        <p:txBody>
+          <a:bodyPr wrap="square" lIns="0" tIns="0" rIns="0" bIns="0" rtlCol="0" anchor="ctr"/>
+          <a:lstStyle/>
+          <a:p>
+            <a:pPr indent="0" marL="0">
+              <a:buNone/>
+            </a:pPr>
+            <a:r>
+              <a:rPr lang="en-US" sz="1150" dirty="0">
+                <a:solidFill>
+                  <a:srgbClr val="F0F0F0"/>
+                </a:solidFill>
+                <a:latin typeface="Calibri" pitchFamily="34" charset="0"/>
+                <a:ea typeface="Calibri" pitchFamily="34" charset="-122"/>
+                <a:cs typeface="Calibri" pitchFamily="34" charset="-120"/>
+              </a:rPr>
+              <a:t>Fornecedores em 100km e equipe</a:t>
+            </a:r>
+            <a:endParaRPr lang="en-US" sz="1150" dirty="0"/>
+          </a:p>
+        </p:txBody>
+      </p:sp>
+      <p:sp>
+        <p:nvSpPr>
+          <p:cNvPr id="20" name="Shape 18"/>
+          <p:cNvSpPr/>
+          <p:nvPr/>
+        </p:nvSpPr>
+        <p:spPr>
+          <a:xfrm>
+            <a:off x="548640" y="4709160"/>
+            <a:ext cx="2606040" cy="1234440"/>
+          </a:xfrm>
+          <a:prstGeom prst="roundRect">
+            <a:avLst>
+              <a:gd name="adj" fmla="val 5926"/>
+            </a:avLst>
+          </a:prstGeom>
+          <a:solidFill>
+            <a:srgbClr val="F7F5EF"/>
+          </a:solidFill>
+          <a:ln/>
+        </p:spPr>
+      </p:sp>
+      <p:sp>
+        <p:nvSpPr>
+          <p:cNvPr id="21" name="Text 19"/>
+          <p:cNvSpPr/>
+          <p:nvPr/>
+        </p:nvSpPr>
+        <p:spPr>
+          <a:xfrm>
+            <a:off x="548640" y="4846320"/>
+            <a:ext cx="2606040" cy="502920"/>
+          </a:xfrm>
+          <a:prstGeom prst="rect">
+            <a:avLst/>
+          </a:prstGeom>
+          <a:noFill/>
+          <a:ln/>
+        </p:spPr>
+        <p:txBody>
+          <a:bodyPr wrap="square" lIns="0" tIns="0" rIns="0" bIns="0" rtlCol="0" anchor="ctr"/>
+          <a:lstStyle/>
+          <a:p>
+            <a:pPr algn="ctr" indent="0" marL="0">
+              <a:buNone/>
+            </a:pPr>
+            <a:r>
+              <a:rPr lang="en-US" sz="2200" b="1" dirty="0">
+                <a:solidFill>
+                  <a:srgbClr val="C97A2B"/>
+                </a:solidFill>
+                <a:latin typeface="Cambria" pitchFamily="34" charset="0"/>
+                <a:ea typeface="Cambria" pitchFamily="34" charset="-122"/>
+                <a:cs typeface="Cambria" pitchFamily="34" charset="-120"/>
+              </a:rPr>
+              <a:t>R$ 60 mil</a:t>
+            </a:r>
+            <a:endParaRPr lang="en-US" sz="2200" dirty="0"/>
+          </a:p>
+        </p:txBody>
+      </p:sp>
+      <p:sp>
+        <p:nvSpPr>
+          <p:cNvPr id="22" name="Text 20"/>
+          <p:cNvSpPr/>
+          <p:nvPr/>
+        </p:nvSpPr>
+        <p:spPr>
+          <a:xfrm>
+            <a:off x="640080" y="5394960"/>
+            <a:ext cx="2423160" cy="457200"/>
+          </a:xfrm>
+          <a:prstGeom prst="rect">
+            <a:avLst/>
+          </a:prstGeom>
+          <a:noFill/>
+          <a:ln/>
+        </p:spPr>
+        <p:txBody>
+          <a:bodyPr wrap="square" lIns="0" tIns="0" rIns="0" bIns="0" rtlCol="0" anchor="ctr"/>
+          <a:lstStyle/>
+          <a:p>
+            <a:pPr algn="ctr" indent="0" marL="0">
+              <a:buNone/>
+            </a:pPr>
+            <a:r>
+              <a:rPr lang="en-US" sz="1000" dirty="0">
+                <a:solidFill>
+                  <a:srgbClr val="5B6B5E"/>
+                </a:solidFill>
+                <a:latin typeface="Calibri" pitchFamily="34" charset="0"/>
+                <a:ea typeface="Calibri" pitchFamily="34" charset="-122"/>
+                <a:cs typeface="Calibri" pitchFamily="34" charset="-120"/>
+              </a:rPr>
+              <a:t>taxa de franquia</a:t>
+            </a:r>
+            <a:endParaRPr lang="en-US" sz="1000" dirty="0"/>
+          </a:p>
+          <a:p>
+            <a:pPr algn="ctr" indent="0" marL="0">
+              <a:buNone/>
+            </a:pPr>
+            <a:r>
+              <a:rPr lang="en-US" sz="1000" dirty="0">
+                <a:solidFill>
+                  <a:srgbClr val="5B6B5E"/>
+                </a:solidFill>
+                <a:latin typeface="Calibri" pitchFamily="34" charset="0"/>
+                <a:ea typeface="Calibri" pitchFamily="34" charset="-122"/>
+                <a:cs typeface="Calibri" pitchFamily="34" charset="-120"/>
+              </a:rPr>
+              <a:t>inicial</a:t>
+            </a:r>
+            <a:endParaRPr lang="en-US" sz="1000" dirty="0"/>
+          </a:p>
+        </p:txBody>
+      </p:sp>
+      <p:sp>
+        <p:nvSpPr>
+          <p:cNvPr id="23" name="Shape 21"/>
+          <p:cNvSpPr/>
+          <p:nvPr/>
+        </p:nvSpPr>
+        <p:spPr>
+          <a:xfrm>
+            <a:off x="3410712" y="4709160"/>
+            <a:ext cx="2606040" cy="1234440"/>
+          </a:xfrm>
+          <a:prstGeom prst="roundRect">
+            <a:avLst>
+              <a:gd name="adj" fmla="val 5926"/>
+            </a:avLst>
+          </a:prstGeom>
+          <a:solidFill>
+            <a:srgbClr val="F7F5EF"/>
+          </a:solidFill>
+          <a:ln/>
+        </p:spPr>
+      </p:sp>
+      <p:sp>
+        <p:nvSpPr>
+          <p:cNvPr id="24" name="Text 22"/>
+          <p:cNvSpPr/>
+          <p:nvPr/>
+        </p:nvSpPr>
+        <p:spPr>
+          <a:xfrm>
+            <a:off x="3410712" y="4846320"/>
+            <a:ext cx="2606040" cy="502920"/>
+          </a:xfrm>
+          <a:prstGeom prst="rect">
+            <a:avLst/>
+          </a:prstGeom>
+          <a:noFill/>
+          <a:ln/>
+        </p:spPr>
+        <p:txBody>
+          <a:bodyPr wrap="square" lIns="0" tIns="0" rIns="0" bIns="0" rtlCol="0" anchor="ctr"/>
+          <a:lstStyle/>
+          <a:p>
+            <a:pPr algn="ctr" indent="0" marL="0">
+              <a:buNone/>
+            </a:pPr>
+            <a:r>
+              <a:rPr lang="en-US" sz="2200" b="1" dirty="0">
+                <a:solidFill>
+                  <a:srgbClr val="C97A2B"/>
+                </a:solidFill>
+                <a:latin typeface="Cambria" pitchFamily="34" charset="0"/>
+                <a:ea typeface="Cambria" pitchFamily="34" charset="-122"/>
+                <a:cs typeface="Cambria" pitchFamily="34" charset="-120"/>
+              </a:rPr>
+              <a:t>5,0%</a:t>
+            </a:r>
+            <a:endParaRPr lang="en-US" sz="2200" dirty="0"/>
+          </a:p>
+        </p:txBody>
+      </p:sp>
+      <p:sp>
+        <p:nvSpPr>
+          <p:cNvPr id="25" name="Text 23"/>
+          <p:cNvSpPr/>
+          <p:nvPr/>
+        </p:nvSpPr>
+        <p:spPr>
+          <a:xfrm>
+            <a:off x="3502152" y="5394960"/>
+            <a:ext cx="2423160" cy="457200"/>
+          </a:xfrm>
+          <a:prstGeom prst="rect">
+            <a:avLst/>
+          </a:prstGeom>
+          <a:noFill/>
+          <a:ln/>
+        </p:spPr>
+        <p:txBody>
+          <a:bodyPr wrap="square" lIns="0" tIns="0" rIns="0" bIns="0" rtlCol="0" anchor="ctr"/>
+          <a:lstStyle/>
+          <a:p>
+            <a:pPr algn="ctr" indent="0" marL="0">
+              <a:buNone/>
+            </a:pPr>
+            <a:r>
+              <a:rPr lang="en-US" sz="1000" dirty="0">
+                <a:solidFill>
+                  <a:srgbClr val="5B6B5E"/>
+                </a:solidFill>
+                <a:latin typeface="Calibri" pitchFamily="34" charset="0"/>
+                <a:ea typeface="Calibri" pitchFamily="34" charset="-122"/>
+                <a:cs typeface="Calibri" pitchFamily="34" charset="-120"/>
+              </a:rPr>
+              <a:t>royalty mensal</a:t>
+            </a:r>
+            <a:endParaRPr lang="en-US" sz="1000" dirty="0"/>
+          </a:p>
+          <a:p>
+            <a:pPr algn="ctr" indent="0" marL="0">
+              <a:buNone/>
+            </a:pPr>
+            <a:r>
+              <a:rPr lang="en-US" sz="1000" dirty="0">
+                <a:solidFill>
+                  <a:srgbClr val="5B6B5E"/>
+                </a:solidFill>
+                <a:latin typeface="Calibri" pitchFamily="34" charset="0"/>
+                <a:ea typeface="Calibri" pitchFamily="34" charset="-122"/>
+                <a:cs typeface="Calibri" pitchFamily="34" charset="-120"/>
+              </a:rPr>
+              <a:t>sobre a receita</a:t>
+            </a:r>
+            <a:endParaRPr lang="en-US" sz="1000" dirty="0"/>
+          </a:p>
+        </p:txBody>
+      </p:sp>
+      <p:sp>
+        <p:nvSpPr>
+          <p:cNvPr id="26" name="Shape 24"/>
+          <p:cNvSpPr/>
+          <p:nvPr/>
+        </p:nvSpPr>
+        <p:spPr>
+          <a:xfrm>
+            <a:off x="6272784" y="4709160"/>
+            <a:ext cx="2606040" cy="1234440"/>
+          </a:xfrm>
+          <a:prstGeom prst="roundRect">
+            <a:avLst>
+              <a:gd name="adj" fmla="val 5926"/>
+            </a:avLst>
+          </a:prstGeom>
+          <a:solidFill>
+            <a:srgbClr val="F7F5EF"/>
+          </a:solidFill>
+          <a:ln/>
+        </p:spPr>
+      </p:sp>
+      <p:sp>
+        <p:nvSpPr>
+          <p:cNvPr id="27" name="Text 25"/>
+          <p:cNvSpPr/>
+          <p:nvPr/>
+        </p:nvSpPr>
+        <p:spPr>
+          <a:xfrm>
+            <a:off x="6272784" y="4846320"/>
+            <a:ext cx="2606040" cy="502920"/>
+          </a:xfrm>
+          <a:prstGeom prst="rect">
+            <a:avLst/>
+          </a:prstGeom>
+          <a:noFill/>
+          <a:ln/>
+        </p:spPr>
+        <p:txBody>
+          <a:bodyPr wrap="square" lIns="0" tIns="0" rIns="0" bIns="0" rtlCol="0" anchor="ctr"/>
+          <a:lstStyle/>
+          <a:p>
+            <a:pPr algn="ctr" indent="0" marL="0">
+              <a:buNone/>
+            </a:pPr>
+            <a:r>
+              <a:rPr lang="en-US" sz="2200" b="1" dirty="0">
+                <a:solidFill>
+                  <a:srgbClr val="C97A2B"/>
+                </a:solidFill>
+                <a:latin typeface="Cambria" pitchFamily="34" charset="0"/>
+                <a:ea typeface="Cambria" pitchFamily="34" charset="-122"/>
+                <a:cs typeface="Cambria" pitchFamily="34" charset="-120"/>
+              </a:rPr>
+              <a:t>1,5%</a:t>
+            </a:r>
+            <a:endParaRPr lang="en-US" sz="2200" dirty="0"/>
+          </a:p>
+        </p:txBody>
+      </p:sp>
+      <p:sp>
+        <p:nvSpPr>
+          <p:cNvPr id="28" name="Text 26"/>
+          <p:cNvSpPr/>
+          <p:nvPr/>
+        </p:nvSpPr>
+        <p:spPr>
+          <a:xfrm>
+            <a:off x="6364224" y="5394960"/>
+            <a:ext cx="2423160" cy="457200"/>
+          </a:xfrm>
+          <a:prstGeom prst="rect">
+            <a:avLst/>
+          </a:prstGeom>
+          <a:noFill/>
+          <a:ln/>
+        </p:spPr>
+        <p:txBody>
+          <a:bodyPr wrap="square" lIns="0" tIns="0" rIns="0" bIns="0" rtlCol="0" anchor="ctr"/>
+          <a:lstStyle/>
+          <a:p>
+            <a:pPr algn="ctr" indent="0" marL="0">
+              <a:buNone/>
+            </a:pPr>
+            <a:r>
+              <a:rPr lang="en-US" sz="1000" dirty="0">
+                <a:solidFill>
+                  <a:srgbClr val="5B6B5E"/>
+                </a:solidFill>
+                <a:latin typeface="Calibri" pitchFamily="34" charset="0"/>
+                <a:ea typeface="Calibri" pitchFamily="34" charset="-122"/>
+                <a:cs typeface="Calibri" pitchFamily="34" charset="-120"/>
+              </a:rPr>
+              <a:t>fundo de</a:t>
+            </a:r>
+            <a:endParaRPr lang="en-US" sz="1000" dirty="0"/>
+          </a:p>
+          <a:p>
+            <a:pPr algn="ctr" indent="0" marL="0">
+              <a:buNone/>
+            </a:pPr>
+            <a:r>
+              <a:rPr lang="en-US" sz="1000" dirty="0">
+                <a:solidFill>
+                  <a:srgbClr val="5B6B5E"/>
+                </a:solidFill>
+                <a:latin typeface="Calibri" pitchFamily="34" charset="0"/>
+                <a:ea typeface="Calibri" pitchFamily="34" charset="-122"/>
+                <a:cs typeface="Calibri" pitchFamily="34" charset="-120"/>
+              </a:rPr>
+              <a:t>marketing</a:t>
+            </a:r>
+            <a:endParaRPr lang="en-US" sz="1000" dirty="0"/>
+          </a:p>
+        </p:txBody>
+      </p:sp>
+      <p:sp>
+        <p:nvSpPr>
+          <p:cNvPr id="29" name="Shape 27"/>
+          <p:cNvSpPr/>
+          <p:nvPr/>
+        </p:nvSpPr>
+        <p:spPr>
+          <a:xfrm>
+            <a:off x="9134856" y="4709160"/>
+            <a:ext cx="2606040" cy="1234440"/>
+          </a:xfrm>
+          <a:prstGeom prst="roundRect">
+            <a:avLst>
+              <a:gd name="adj" fmla="val 5926"/>
+            </a:avLst>
+          </a:prstGeom>
+          <a:solidFill>
+            <a:srgbClr val="F7F5EF"/>
+          </a:solidFill>
+          <a:ln/>
+        </p:spPr>
+      </p:sp>
+      <p:sp>
+        <p:nvSpPr>
+          <p:cNvPr id="30" name="Text 28"/>
+          <p:cNvSpPr/>
+          <p:nvPr/>
+        </p:nvSpPr>
+        <p:spPr>
+          <a:xfrm>
+            <a:off x="9134856" y="4846320"/>
+            <a:ext cx="2606040" cy="502920"/>
+          </a:xfrm>
+          <a:prstGeom prst="rect">
+            <a:avLst/>
+          </a:prstGeom>
+          <a:noFill/>
+          <a:ln/>
+        </p:spPr>
+        <p:txBody>
+          <a:bodyPr wrap="square" lIns="0" tIns="0" rIns="0" bIns="0" rtlCol="0" anchor="ctr"/>
+          <a:lstStyle/>
+          <a:p>
+            <a:pPr algn="ctr" indent="0" marL="0">
+              <a:buNone/>
+            </a:pPr>
+            <a:r>
+              <a:rPr lang="en-US" sz="2200" b="1" dirty="0">
+                <a:solidFill>
+                  <a:srgbClr val="C97A2B"/>
+                </a:solidFill>
+                <a:latin typeface="Cambria" pitchFamily="34" charset="0"/>
+                <a:ea typeface="Cambria" pitchFamily="34" charset="-122"/>
+                <a:cs typeface="Cambria" pitchFamily="34" charset="-120"/>
+              </a:rPr>
+              <a:t>~15–21m</a:t>
+            </a:r>
+            <a:endParaRPr lang="en-US" sz="2200" dirty="0"/>
+          </a:p>
+        </p:txBody>
+      </p:sp>
+      <p:sp>
+        <p:nvSpPr>
+          <p:cNvPr id="31" name="Text 29"/>
+          <p:cNvSpPr/>
+          <p:nvPr/>
+        </p:nvSpPr>
+        <p:spPr>
+          <a:xfrm>
+            <a:off x="9226296" y="5394960"/>
+            <a:ext cx="2423160" cy="457200"/>
+          </a:xfrm>
+          <a:prstGeom prst="rect">
+            <a:avLst/>
+          </a:prstGeom>
+          <a:noFill/>
+          <a:ln/>
+        </p:spPr>
+        <p:txBody>
+          <a:bodyPr wrap="square" lIns="0" tIns="0" rIns="0" bIns="0" rtlCol="0" anchor="ctr"/>
+          <a:lstStyle/>
+          <a:p>
+            <a:pPr algn="ctr" indent="0" marL="0">
+              <a:buNone/>
+            </a:pPr>
+            <a:r>
+              <a:rPr lang="en-US" sz="1000" dirty="0">
+                <a:solidFill>
+                  <a:srgbClr val="5B6B5E"/>
+                </a:solidFill>
+                <a:latin typeface="Calibri" pitchFamily="34" charset="0"/>
+                <a:ea typeface="Calibri" pitchFamily="34" charset="-122"/>
+                <a:cs typeface="Calibri" pitchFamily="34" charset="-120"/>
+              </a:rPr>
+              <a:t>payback do</a:t>
+            </a:r>
+            <a:endParaRPr lang="en-US" sz="1000" dirty="0"/>
+          </a:p>
+          <a:p>
+            <a:pPr algn="ctr" indent="0" marL="0">
+              <a:buNone/>
+            </a:pPr>
+            <a:r>
+              <a:rPr lang="en-US" sz="1000" dirty="0">
+                <a:solidFill>
+                  <a:srgbClr val="5B6B5E"/>
+                </a:solidFill>
+                <a:latin typeface="Calibri" pitchFamily="34" charset="0"/>
+                <a:ea typeface="Calibri" pitchFamily="34" charset="-122"/>
+                <a:cs typeface="Calibri" pitchFamily="34" charset="-120"/>
+              </a:rPr>
+              <a:t>franqueado</a:t>
+            </a:r>
+            <a:endParaRPr lang="en-US" sz="1000" dirty="0"/>
+          </a:p>
+        </p:txBody>
+      </p:sp>
+      <p:sp>
+        <p:nvSpPr>
+          <p:cNvPr id="32" name="Text 30"/>
+          <p:cNvSpPr/>
+          <p:nvPr/>
+        </p:nvSpPr>
+        <p:spPr>
+          <a:xfrm>
+            <a:off x="457200" y="6510528"/>
+            <a:ext cx="7315200" cy="274320"/>
+          </a:xfrm>
+          <a:prstGeom prst="rect">
+            <a:avLst/>
+          </a:prstGeom>
+          <a:noFill/>
+          <a:ln/>
+        </p:spPr>
+        <p:txBody>
+          <a:bodyPr wrap="square" lIns="0" tIns="0" rIns="0" bIns="0" rtlCol="0" anchor="ctr"/>
+          <a:lstStyle/>
+          <a:p>
+            <a:pPr indent="0" marL="0">
+              <a:buNone/>
+            </a:pPr>
+            <a:r>
+              <a:rPr lang="en-US" sz="900" dirty="0">
+                <a:solidFill>
+                  <a:srgbClr val="5B6B5E"/>
+                </a:solidFill>
+                <a:latin typeface="Calibri" pitchFamily="34" charset="0"/>
+                <a:ea typeface="Calibri" pitchFamily="34" charset="-122"/>
+                <a:cs typeface="Calibri" pitchFamily="34" charset="-120"/>
+              </a:rPr>
+              <a:t>Clube.org — Plano de Negócios &amp; Investimento</a:t>
+            </a:r>
+            <a:endParaRPr lang="en-US" sz="900" dirty="0"/>
+          </a:p>
+        </p:txBody>
+      </p:sp>
+      <p:sp>
+        <p:nvSpPr>
+          <p:cNvPr id="33" name="Text 31"/>
+          <p:cNvSpPr/>
+          <p:nvPr/>
+        </p:nvSpPr>
+        <p:spPr>
+          <a:xfrm>
+            <a:off x="11430000" y="6510528"/>
+            <a:ext cx="365760" cy="274320"/>
+          </a:xfrm>
+          <a:prstGeom prst="rect">
+            <a:avLst/>
+          </a:prstGeom>
+          <a:noFill/>
+          <a:ln/>
+        </p:spPr>
+        <p:txBody>
+          <a:bodyPr wrap="square" lIns="0" tIns="0" rIns="0" bIns="0" rtlCol="0" anchor="ctr"/>
+          <a:lstStyle/>
+          <a:p>
+            <a:pPr algn="r" indent="0" marL="0">
+              <a:buNone/>
+            </a:pPr>
+            <a:r>
+              <a:rPr lang="en-US" sz="900" dirty="0">
+                <a:solidFill>
+                  <a:srgbClr val="5B6B5E"/>
+                </a:solidFill>
+                <a:latin typeface="Calibri" pitchFamily="34" charset="0"/>
+                <a:ea typeface="Calibri" pitchFamily="34" charset="-122"/>
+                <a:cs typeface="Calibri" pitchFamily="34" charset="-120"/>
+              </a:rPr>
+              <a:t>15</a:t>
+            </a:r>
+            <a:endParaRPr lang="en-US" sz="900" dirty="0"/>
+          </a:p>
+        </p:txBody>
+      </p:sp>
+    </p:spTree>
+  </p:cSld>
+  <p:clrMapOvr>
+    <a:masterClrMapping/>
+  </p:clrMapOvr>
+</p:sld>
+</file>
+
+<file path=ppt/slides/slide16.xml><?xml version="1.0" encoding="utf-8"?>
+<p:sld xmlns:a="http://schemas.openxmlformats.org/drawingml/2006/main" xmlns:r="http://schemas.openxmlformats.org/officeDocument/2006/relationships" xmlns:p="http://schemas.openxmlformats.org/presentationml/2006/main">
+  <p:cSld name="Slide 16">
+    <p:bg>
+      <p:bgPr>
+        <a:solidFill>
+          <a:srgbClr val="1F3D24"/>
+        </a:solidFill>
+      </p:bgPr>
+    </p:bg>
+    <p:spTree>
+      <p:nvGrpSpPr>
+        <p:cNvPr id="1" name=""/>
+        <p:cNvGrpSpPr/>
+        <p:nvPr/>
+      </p:nvGrpSpPr>
+      <p:grpSpPr>
+        <a:xfrm>
+          <a:off x="0" y="0"/>
+          <a:ext cx="0" cy="0"/>
+          <a:chOff x="0" y="0"/>
+          <a:chExt cx="0" cy="0"/>
+        </a:xfrm>
+      </p:grpSpPr>
+      <p:sp>
+        <p:nvSpPr>
           <p:cNvPr id="2" name="Shape 0"/>
           <p:cNvSpPr/>
           <p:nvPr/>

</xml_diff>